<commit_message>
1.0.0: follow links to other presentations and custom shows, sharp slides for the phone, README, release workflow
Co-Authored-By: Claude Opus 5.5 <noreply@anthropic.com>
</commit_message>
<xml_diff>
--- a/test/test.pptx
+++ b/test/test.pptx
@@ -116,21 +116,21 @@
   <p:extLst>
     <p:ext uri="{521415D9-36F7-43E2-AB2F-B90AF26B5E84}">
       <p14:sectionLst xmlns:p14="http://schemas.microsoft.com/office/powerpoint/2010/main">
-        <p14:section name="Opening" id="{97CF3244-9BA1-457D-BBCB-D5E22E67D1FF}">
+        <p14:section name="Opening" id="{E14EBF6A-C4B1-4DF8-8DED-2D5241848DF7}">
           <p14:sldIdLst>
             <p14:sldId id="256"/>
             <p14:sldId id="257"/>
             <p14:sldId id="258"/>
           </p14:sldIdLst>
         </p14:section>
-        <p14:section name="Sermon" id="{3CE441EB-9FEB-4186-A333-26F724BE473A}">
+        <p14:section name="Sermon" id="{6E5E5EB7-9EA6-4A4F-9490-DA8DD880AED9}">
           <p14:sldIdLst>
             <p14:sldId id="259"/>
             <p14:sldId id="260"/>
             <p14:sldId id="261"/>
           </p14:sldIdLst>
         </p14:section>
-        <p14:section name="Hymns" id="{357274AF-1C76-4214-84B0-F33EA53519BC}">
+        <p14:section name="Hymns" id="{AB361F78-34C0-4B02-BC98-5A8B0D99F9E1}">
           <p14:sldIdLst>
             <p14:sldId id="262"/>
           </p14:sldIdLst>
@@ -221,7 +221,7 @@
             </a:lvl1pPr>
           </a:lstStyle>
           <a:p>
-            <a:fld id="{26EAD3F5-6DEF-4600-99F4-7FD344AD3BE6}" type="datetimeFigureOut">
+            <a:fld id="{828708B5-9781-4D87-B880-8B7DD460CB80}" type="datetimeFigureOut">
               <a:rPr lang="en-US" smtClean="0"/>
               <a:t>21-Oct-26</a:t>
             </a:fld>
@@ -379,7 +379,7 @@
             </a:lvl1pPr>
           </a:lstStyle>
           <a:p>
-            <a:fld id="{83549BE1-1D47-470A-BA87-877381117449}" type="slidenum">
+            <a:fld id="{5969A61C-7E51-480D-83A7-01F53901A93E}" type="slidenum">
               <a:rPr lang="en-US" smtClean="0"/>
               <a:t>‹#›</a:t>
             </a:fld>
@@ -390,7 +390,7 @@
     </p:spTree>
     <p:extLst>
       <p:ext uri="{BB962C8B-B14F-4D97-AF65-F5344CB8AC3E}">
-        <p14:creationId xmlns:p14="http://schemas.microsoft.com/office/powerpoint/2010/main" val="3427842171"/>
+        <p14:creationId xmlns:p14="http://schemas.microsoft.com/office/powerpoint/2010/main" val="3272172018"/>
       </p:ext>
     </p:extLst>
   </p:cSld>
@@ -556,7 +556,7 @@
           <a:bodyPr/>
           <a:lstStyle/>
           <a:p>
-            <a:fld id="{83549BE1-1D47-470A-BA87-877381117449}" type="slidenum">
+            <a:fld id="{5969A61C-7E51-480D-83A7-01F53901A93E}" type="slidenum">
               <a:rPr lang="en-US" smtClean="0"/>
               <a:t>1</a:t>
             </a:fld>
@@ -567,7 +567,7 @@
     </p:spTree>
     <p:extLst>
       <p:ext uri="{BB962C8B-B14F-4D97-AF65-F5344CB8AC3E}">
-        <p14:creationId xmlns:p14="http://schemas.microsoft.com/office/powerpoint/2010/main" val="2342085966"/>
+        <p14:creationId xmlns:p14="http://schemas.microsoft.com/office/powerpoint/2010/main" val="1414171740"/>
       </p:ext>
     </p:extLst>
   </p:cSld>
@@ -643,7 +643,7 @@
           <a:bodyPr/>
           <a:lstStyle/>
           <a:p>
-            <a:fld id="{83549BE1-1D47-470A-BA87-877381117449}" type="slidenum">
+            <a:fld id="{5969A61C-7E51-480D-83A7-01F53901A93E}" type="slidenum">
               <a:rPr lang="en-US" smtClean="0"/>
               <a:t>2</a:t>
             </a:fld>
@@ -654,7 +654,7 @@
     </p:spTree>
     <p:extLst>
       <p:ext uri="{BB962C8B-B14F-4D97-AF65-F5344CB8AC3E}">
-        <p14:creationId xmlns:p14="http://schemas.microsoft.com/office/powerpoint/2010/main" val="2852675775"/>
+        <p14:creationId xmlns:p14="http://schemas.microsoft.com/office/powerpoint/2010/main" val="1517201183"/>
       </p:ext>
     </p:extLst>
   </p:cSld>
@@ -730,7 +730,7 @@
           <a:bodyPr/>
           <a:lstStyle/>
           <a:p>
-            <a:fld id="{83549BE1-1D47-470A-BA87-877381117449}" type="slidenum">
+            <a:fld id="{5969A61C-7E51-480D-83A7-01F53901A93E}" type="slidenum">
               <a:rPr lang="en-US" smtClean="0"/>
               <a:t>3</a:t>
             </a:fld>
@@ -741,7 +741,7 @@
     </p:spTree>
     <p:extLst>
       <p:ext uri="{BB962C8B-B14F-4D97-AF65-F5344CB8AC3E}">
-        <p14:creationId xmlns:p14="http://schemas.microsoft.com/office/powerpoint/2010/main" val="877332355"/>
+        <p14:creationId xmlns:p14="http://schemas.microsoft.com/office/powerpoint/2010/main" val="3870889607"/>
       </p:ext>
     </p:extLst>
   </p:cSld>
@@ -817,7 +817,7 @@
           <a:bodyPr/>
           <a:lstStyle/>
           <a:p>
-            <a:fld id="{83549BE1-1D47-470A-BA87-877381117449}" type="slidenum">
+            <a:fld id="{5969A61C-7E51-480D-83A7-01F53901A93E}" type="slidenum">
               <a:rPr lang="en-US" smtClean="0"/>
               <a:t>4</a:t>
             </a:fld>
@@ -828,7 +828,7 @@
     </p:spTree>
     <p:extLst>
       <p:ext uri="{BB962C8B-B14F-4D97-AF65-F5344CB8AC3E}">
-        <p14:creationId xmlns:p14="http://schemas.microsoft.com/office/powerpoint/2010/main" val="1168628625"/>
+        <p14:creationId xmlns:p14="http://schemas.microsoft.com/office/powerpoint/2010/main" val="1792313637"/>
       </p:ext>
     </p:extLst>
   </p:cSld>
@@ -904,7 +904,7 @@
           <a:bodyPr/>
           <a:lstStyle/>
           <a:p>
-            <a:fld id="{83549BE1-1D47-470A-BA87-877381117449}" type="slidenum">
+            <a:fld id="{5969A61C-7E51-480D-83A7-01F53901A93E}" type="slidenum">
               <a:rPr lang="en-US" smtClean="0"/>
               <a:t>5</a:t>
             </a:fld>
@@ -915,7 +915,7 @@
     </p:spTree>
     <p:extLst>
       <p:ext uri="{BB962C8B-B14F-4D97-AF65-F5344CB8AC3E}">
-        <p14:creationId xmlns:p14="http://schemas.microsoft.com/office/powerpoint/2010/main" val="3010712528"/>
+        <p14:creationId xmlns:p14="http://schemas.microsoft.com/office/powerpoint/2010/main" val="636696452"/>
       </p:ext>
     </p:extLst>
   </p:cSld>
@@ -991,7 +991,7 @@
           <a:bodyPr/>
           <a:lstStyle/>
           <a:p>
-            <a:fld id="{83549BE1-1D47-470A-BA87-877381117449}" type="slidenum">
+            <a:fld id="{5969A61C-7E51-480D-83A7-01F53901A93E}" type="slidenum">
               <a:rPr lang="en-US" smtClean="0"/>
               <a:t>6</a:t>
             </a:fld>
@@ -1002,7 +1002,7 @@
     </p:spTree>
     <p:extLst>
       <p:ext uri="{BB962C8B-B14F-4D97-AF65-F5344CB8AC3E}">
-        <p14:creationId xmlns:p14="http://schemas.microsoft.com/office/powerpoint/2010/main" val="124993536"/>
+        <p14:creationId xmlns:p14="http://schemas.microsoft.com/office/powerpoint/2010/main" val="2094330177"/>
       </p:ext>
     </p:extLst>
   </p:cSld>
@@ -1078,7 +1078,7 @@
           <a:bodyPr/>
           <a:lstStyle/>
           <a:p>
-            <a:fld id="{83549BE1-1D47-470A-BA87-877381117449}" type="slidenum">
+            <a:fld id="{5969A61C-7E51-480D-83A7-01F53901A93E}" type="slidenum">
               <a:rPr lang="en-US" smtClean="0"/>
               <a:t>7</a:t>
             </a:fld>
@@ -1089,7 +1089,7 @@
     </p:spTree>
     <p:extLst>
       <p:ext uri="{BB962C8B-B14F-4D97-AF65-F5344CB8AC3E}">
-        <p14:creationId xmlns:p14="http://schemas.microsoft.com/office/powerpoint/2010/main" val="1723673917"/>
+        <p14:creationId xmlns:p14="http://schemas.microsoft.com/office/powerpoint/2010/main" val="3219653683"/>
       </p:ext>
     </p:extLst>
   </p:cSld>
@@ -1121,7 +1121,7 @@
           <p:cNvPr id="2" name="Title 1">
             <a:extLst>
               <a:ext uri="{FF2B5EF4-FFF2-40B4-BE49-F238E27FC236}">
-                <a16:creationId xmlns:a16="http://schemas.microsoft.com/office/drawing/2014/main" id="{5E8E3045-8308-6E78-AD23-F0EC44BA95CA}"/>
+                <a16:creationId xmlns:a16="http://schemas.microsoft.com/office/drawing/2014/main" id="{A5B78CD0-B01D-3A9C-41A8-57EA1AB6C3D1}"/>
               </a:ext>
             </a:extLst>
           </p:cNvPr>
@@ -1158,7 +1158,7 @@
           <p:cNvPr id="3" name="Subtitle 2">
             <a:extLst>
               <a:ext uri="{FF2B5EF4-FFF2-40B4-BE49-F238E27FC236}">
-                <a16:creationId xmlns:a16="http://schemas.microsoft.com/office/drawing/2014/main" id="{853CE75F-C183-89F7-10F6-399DB74E4A93}"/>
+                <a16:creationId xmlns:a16="http://schemas.microsoft.com/office/drawing/2014/main" id="{8B46E41C-4D5E-F24D-8C85-F0374FBAD3B2}"/>
               </a:ext>
             </a:extLst>
           </p:cNvPr>
@@ -1228,7 +1228,7 @@
           <p:cNvPr id="4" name="Date Placeholder 3">
             <a:extLst>
               <a:ext uri="{FF2B5EF4-FFF2-40B4-BE49-F238E27FC236}">
-                <a16:creationId xmlns:a16="http://schemas.microsoft.com/office/drawing/2014/main" id="{900C650E-C50F-54B0-1A25-256AD02D1258}"/>
+                <a16:creationId xmlns:a16="http://schemas.microsoft.com/office/drawing/2014/main" id="{2D8B5C1F-C004-30F8-754A-2FA6C8058D25}"/>
               </a:ext>
             </a:extLst>
           </p:cNvPr>
@@ -1244,7 +1244,7 @@
           <a:bodyPr/>
           <a:lstStyle/>
           <a:p>
-            <a:fld id="{F977BB9B-F59E-4A9E-8FB1-55369D431D5A}" type="datetimeFigureOut">
+            <a:fld id="{1DDD3D51-C5CB-4127-A8E5-A017D0F1E954}" type="datetimeFigureOut">
               <a:rPr lang="en-US" smtClean="0"/>
               <a:t>21-Oct-26</a:t>
             </a:fld>
@@ -1257,7 +1257,7 @@
           <p:cNvPr id="5" name="Footer Placeholder 4">
             <a:extLst>
               <a:ext uri="{FF2B5EF4-FFF2-40B4-BE49-F238E27FC236}">
-                <a16:creationId xmlns:a16="http://schemas.microsoft.com/office/drawing/2014/main" id="{94772F76-6E91-2560-3EC2-3E11D98E377A}"/>
+                <a16:creationId xmlns:a16="http://schemas.microsoft.com/office/drawing/2014/main" id="{5023D181-E109-4E68-D033-87858666472D}"/>
               </a:ext>
             </a:extLst>
           </p:cNvPr>
@@ -1282,7 +1282,7 @@
           <p:cNvPr id="6" name="Slide Number Placeholder 5">
             <a:extLst>
               <a:ext uri="{FF2B5EF4-FFF2-40B4-BE49-F238E27FC236}">
-                <a16:creationId xmlns:a16="http://schemas.microsoft.com/office/drawing/2014/main" id="{A88F3043-0985-DA24-8AAA-D3BBAE2D1B9D}"/>
+                <a16:creationId xmlns:a16="http://schemas.microsoft.com/office/drawing/2014/main" id="{16AF1EF2-B261-7EA8-C5FA-B617285D3893}"/>
               </a:ext>
             </a:extLst>
           </p:cNvPr>
@@ -1298,7 +1298,7 @@
           <a:bodyPr/>
           <a:lstStyle/>
           <a:p>
-            <a:fld id="{33AD01C5-AFAF-4916-9B99-98696E38DFA9}" type="slidenum">
+            <a:fld id="{F51E3BCC-0CEF-42DB-943A-D6620B5890DC}" type="slidenum">
               <a:rPr lang="en-US" smtClean="0"/>
               <a:t>‹#›</a:t>
             </a:fld>
@@ -1309,7 +1309,7 @@
     </p:spTree>
     <p:extLst>
       <p:ext uri="{BB962C8B-B14F-4D97-AF65-F5344CB8AC3E}">
-        <p14:creationId xmlns:p14="http://schemas.microsoft.com/office/powerpoint/2010/main" val="3012296963"/>
+        <p14:creationId xmlns:p14="http://schemas.microsoft.com/office/powerpoint/2010/main" val="3253388203"/>
       </p:ext>
     </p:extLst>
   </p:cSld>
@@ -1341,7 +1341,7 @@
           <p:cNvPr id="2" name="Title 1">
             <a:extLst>
               <a:ext uri="{FF2B5EF4-FFF2-40B4-BE49-F238E27FC236}">
-                <a16:creationId xmlns:a16="http://schemas.microsoft.com/office/drawing/2014/main" id="{77E98281-AB4A-60CF-9B9D-3CEABE1B51EC}"/>
+                <a16:creationId xmlns:a16="http://schemas.microsoft.com/office/drawing/2014/main" id="{52494780-FD18-8679-70C6-F654CBBDE4F8}"/>
               </a:ext>
             </a:extLst>
           </p:cNvPr>
@@ -1369,7 +1369,7 @@
           <p:cNvPr id="3" name="Vertical Text Placeholder 2">
             <a:extLst>
               <a:ext uri="{FF2B5EF4-FFF2-40B4-BE49-F238E27FC236}">
-                <a16:creationId xmlns:a16="http://schemas.microsoft.com/office/drawing/2014/main" id="{96AE6501-743F-0A63-47E8-7EAA2310ADFB}"/>
+                <a16:creationId xmlns:a16="http://schemas.microsoft.com/office/drawing/2014/main" id="{FB00B7E0-3CBF-E661-C4BF-1E4DFC31C812}"/>
               </a:ext>
             </a:extLst>
           </p:cNvPr>
@@ -1426,7 +1426,7 @@
           <p:cNvPr id="4" name="Date Placeholder 3">
             <a:extLst>
               <a:ext uri="{FF2B5EF4-FFF2-40B4-BE49-F238E27FC236}">
-                <a16:creationId xmlns:a16="http://schemas.microsoft.com/office/drawing/2014/main" id="{80A43242-5E87-C756-5675-0A1B9CA2A00E}"/>
+                <a16:creationId xmlns:a16="http://schemas.microsoft.com/office/drawing/2014/main" id="{3C799445-E862-5A31-C312-DC3187229944}"/>
               </a:ext>
             </a:extLst>
           </p:cNvPr>
@@ -1442,7 +1442,7 @@
           <a:bodyPr/>
           <a:lstStyle/>
           <a:p>
-            <a:fld id="{F977BB9B-F59E-4A9E-8FB1-55369D431D5A}" type="datetimeFigureOut">
+            <a:fld id="{1DDD3D51-C5CB-4127-A8E5-A017D0F1E954}" type="datetimeFigureOut">
               <a:rPr lang="en-US" smtClean="0"/>
               <a:t>21-Oct-26</a:t>
             </a:fld>
@@ -1455,7 +1455,7 @@
           <p:cNvPr id="5" name="Footer Placeholder 4">
             <a:extLst>
               <a:ext uri="{FF2B5EF4-FFF2-40B4-BE49-F238E27FC236}">
-                <a16:creationId xmlns:a16="http://schemas.microsoft.com/office/drawing/2014/main" id="{D068DF17-B258-1E9C-7204-70ECD7220475}"/>
+                <a16:creationId xmlns:a16="http://schemas.microsoft.com/office/drawing/2014/main" id="{3F3F9B96-9DFA-5741-4D52-E64689C7C58D}"/>
               </a:ext>
             </a:extLst>
           </p:cNvPr>
@@ -1480,7 +1480,7 @@
           <p:cNvPr id="6" name="Slide Number Placeholder 5">
             <a:extLst>
               <a:ext uri="{FF2B5EF4-FFF2-40B4-BE49-F238E27FC236}">
-                <a16:creationId xmlns:a16="http://schemas.microsoft.com/office/drawing/2014/main" id="{D1501511-C380-FAF2-E3CA-24AF551BD8BC}"/>
+                <a16:creationId xmlns:a16="http://schemas.microsoft.com/office/drawing/2014/main" id="{3FA92F0C-32B1-8785-1E7D-5E45BDF61795}"/>
               </a:ext>
             </a:extLst>
           </p:cNvPr>
@@ -1496,7 +1496,7 @@
           <a:bodyPr/>
           <a:lstStyle/>
           <a:p>
-            <a:fld id="{33AD01C5-AFAF-4916-9B99-98696E38DFA9}" type="slidenum">
+            <a:fld id="{F51E3BCC-0CEF-42DB-943A-D6620B5890DC}" type="slidenum">
               <a:rPr lang="en-US" smtClean="0"/>
               <a:t>‹#›</a:t>
             </a:fld>
@@ -1507,7 +1507,7 @@
     </p:spTree>
     <p:extLst>
       <p:ext uri="{BB962C8B-B14F-4D97-AF65-F5344CB8AC3E}">
-        <p14:creationId xmlns:p14="http://schemas.microsoft.com/office/powerpoint/2010/main" val="4240249883"/>
+        <p14:creationId xmlns:p14="http://schemas.microsoft.com/office/powerpoint/2010/main" val="1734874900"/>
       </p:ext>
     </p:extLst>
   </p:cSld>
@@ -1539,7 +1539,7 @@
           <p:cNvPr id="2" name="Vertical Title 1">
             <a:extLst>
               <a:ext uri="{FF2B5EF4-FFF2-40B4-BE49-F238E27FC236}">
-                <a16:creationId xmlns:a16="http://schemas.microsoft.com/office/drawing/2014/main" id="{DC4AD869-755F-371F-FEC6-29B23F1C3189}"/>
+                <a16:creationId xmlns:a16="http://schemas.microsoft.com/office/drawing/2014/main" id="{4A831583-FD3B-538A-8864-427657334E49}"/>
               </a:ext>
             </a:extLst>
           </p:cNvPr>
@@ -1572,7 +1572,7 @@
           <p:cNvPr id="3" name="Vertical Text Placeholder 2">
             <a:extLst>
               <a:ext uri="{FF2B5EF4-FFF2-40B4-BE49-F238E27FC236}">
-                <a16:creationId xmlns:a16="http://schemas.microsoft.com/office/drawing/2014/main" id="{FC495F7C-1554-776A-E8C8-E6130BCE5246}"/>
+                <a16:creationId xmlns:a16="http://schemas.microsoft.com/office/drawing/2014/main" id="{1CF7118E-3C0F-17D5-3D33-B9B707207D37}"/>
               </a:ext>
             </a:extLst>
           </p:cNvPr>
@@ -1634,7 +1634,7 @@
           <p:cNvPr id="4" name="Date Placeholder 3">
             <a:extLst>
               <a:ext uri="{FF2B5EF4-FFF2-40B4-BE49-F238E27FC236}">
-                <a16:creationId xmlns:a16="http://schemas.microsoft.com/office/drawing/2014/main" id="{83695C3C-4190-25D9-585E-507647C7EED9}"/>
+                <a16:creationId xmlns:a16="http://schemas.microsoft.com/office/drawing/2014/main" id="{DE6001A3-21B2-1F36-CE20-062AF14A917A}"/>
               </a:ext>
             </a:extLst>
           </p:cNvPr>
@@ -1650,7 +1650,7 @@
           <a:bodyPr/>
           <a:lstStyle/>
           <a:p>
-            <a:fld id="{F977BB9B-F59E-4A9E-8FB1-55369D431D5A}" type="datetimeFigureOut">
+            <a:fld id="{1DDD3D51-C5CB-4127-A8E5-A017D0F1E954}" type="datetimeFigureOut">
               <a:rPr lang="en-US" smtClean="0"/>
               <a:t>21-Oct-26</a:t>
             </a:fld>
@@ -1663,7 +1663,7 @@
           <p:cNvPr id="5" name="Footer Placeholder 4">
             <a:extLst>
               <a:ext uri="{FF2B5EF4-FFF2-40B4-BE49-F238E27FC236}">
-                <a16:creationId xmlns:a16="http://schemas.microsoft.com/office/drawing/2014/main" id="{C25ED769-2C62-841A-6FCB-BC42D1D45A48}"/>
+                <a16:creationId xmlns:a16="http://schemas.microsoft.com/office/drawing/2014/main" id="{5D77A9E5-76B9-CA76-E65F-DDBF44345131}"/>
               </a:ext>
             </a:extLst>
           </p:cNvPr>
@@ -1688,7 +1688,7 @@
           <p:cNvPr id="6" name="Slide Number Placeholder 5">
             <a:extLst>
               <a:ext uri="{FF2B5EF4-FFF2-40B4-BE49-F238E27FC236}">
-                <a16:creationId xmlns:a16="http://schemas.microsoft.com/office/drawing/2014/main" id="{68B911B7-1A1D-2409-E4B7-16AC82C49181}"/>
+                <a16:creationId xmlns:a16="http://schemas.microsoft.com/office/drawing/2014/main" id="{F86F2289-413D-99C4-4554-8D53EB850B2F}"/>
               </a:ext>
             </a:extLst>
           </p:cNvPr>
@@ -1704,7 +1704,7 @@
           <a:bodyPr/>
           <a:lstStyle/>
           <a:p>
-            <a:fld id="{33AD01C5-AFAF-4916-9B99-98696E38DFA9}" type="slidenum">
+            <a:fld id="{F51E3BCC-0CEF-42DB-943A-D6620B5890DC}" type="slidenum">
               <a:rPr lang="en-US" smtClean="0"/>
               <a:t>‹#›</a:t>
             </a:fld>
@@ -1715,7 +1715,7 @@
     </p:spTree>
     <p:extLst>
       <p:ext uri="{BB962C8B-B14F-4D97-AF65-F5344CB8AC3E}">
-        <p14:creationId xmlns:p14="http://schemas.microsoft.com/office/powerpoint/2010/main" val="3814855338"/>
+        <p14:creationId xmlns:p14="http://schemas.microsoft.com/office/powerpoint/2010/main" val="92215184"/>
       </p:ext>
     </p:extLst>
   </p:cSld>
@@ -1747,7 +1747,7 @@
           <p:cNvPr id="2" name="Title 1">
             <a:extLst>
               <a:ext uri="{FF2B5EF4-FFF2-40B4-BE49-F238E27FC236}">
-                <a16:creationId xmlns:a16="http://schemas.microsoft.com/office/drawing/2014/main" id="{4449E216-6F72-5A57-68B8-F25700987C3C}"/>
+                <a16:creationId xmlns:a16="http://schemas.microsoft.com/office/drawing/2014/main" id="{88437742-C171-D83C-16C6-B46F741B51E8}"/>
               </a:ext>
             </a:extLst>
           </p:cNvPr>
@@ -1775,7 +1775,7 @@
           <p:cNvPr id="3" name="Text Placeholder 2">
             <a:extLst>
               <a:ext uri="{FF2B5EF4-FFF2-40B4-BE49-F238E27FC236}">
-                <a16:creationId xmlns:a16="http://schemas.microsoft.com/office/drawing/2014/main" id="{6AA75C07-9A75-25B7-4766-960929852D70}"/>
+                <a16:creationId xmlns:a16="http://schemas.microsoft.com/office/drawing/2014/main" id="{C31705FC-48E3-9978-342D-E7EACAC82DDC}"/>
               </a:ext>
             </a:extLst>
           </p:cNvPr>
@@ -1832,7 +1832,7 @@
           <p:cNvPr id="4" name="Date Placeholder 3">
             <a:extLst>
               <a:ext uri="{FF2B5EF4-FFF2-40B4-BE49-F238E27FC236}">
-                <a16:creationId xmlns:a16="http://schemas.microsoft.com/office/drawing/2014/main" id="{E37BF7C8-0CB1-C30D-FF11-5649136F2619}"/>
+                <a16:creationId xmlns:a16="http://schemas.microsoft.com/office/drawing/2014/main" id="{42C11F13-FFFA-D50E-C4D4-1BFD703339CE}"/>
               </a:ext>
             </a:extLst>
           </p:cNvPr>
@@ -1848,7 +1848,7 @@
           <a:bodyPr/>
           <a:lstStyle/>
           <a:p>
-            <a:fld id="{F977BB9B-F59E-4A9E-8FB1-55369D431D5A}" type="datetimeFigureOut">
+            <a:fld id="{1DDD3D51-C5CB-4127-A8E5-A017D0F1E954}" type="datetimeFigureOut">
               <a:rPr lang="en-US" smtClean="0"/>
               <a:t>21-Oct-26</a:t>
             </a:fld>
@@ -1861,7 +1861,7 @@
           <p:cNvPr id="5" name="Footer Placeholder 4">
             <a:extLst>
               <a:ext uri="{FF2B5EF4-FFF2-40B4-BE49-F238E27FC236}">
-                <a16:creationId xmlns:a16="http://schemas.microsoft.com/office/drawing/2014/main" id="{937B6863-5D82-8365-C63A-B4FA3FCAC330}"/>
+                <a16:creationId xmlns:a16="http://schemas.microsoft.com/office/drawing/2014/main" id="{549CD982-EF68-E2FA-80D6-2B4F202EA507}"/>
               </a:ext>
             </a:extLst>
           </p:cNvPr>
@@ -1886,7 +1886,7 @@
           <p:cNvPr id="6" name="Slide Number Placeholder 5">
             <a:extLst>
               <a:ext uri="{FF2B5EF4-FFF2-40B4-BE49-F238E27FC236}">
-                <a16:creationId xmlns:a16="http://schemas.microsoft.com/office/drawing/2014/main" id="{B30453B4-92FD-3E57-D0F8-0DBE5ACA4D8F}"/>
+                <a16:creationId xmlns:a16="http://schemas.microsoft.com/office/drawing/2014/main" id="{34AEC9EA-729C-3690-FE01-F43CF3B7BF8E}"/>
               </a:ext>
             </a:extLst>
           </p:cNvPr>
@@ -1902,7 +1902,7 @@
           <a:bodyPr/>
           <a:lstStyle/>
           <a:p>
-            <a:fld id="{33AD01C5-AFAF-4916-9B99-98696E38DFA9}" type="slidenum">
+            <a:fld id="{F51E3BCC-0CEF-42DB-943A-D6620B5890DC}" type="slidenum">
               <a:rPr lang="en-US" smtClean="0"/>
               <a:t>‹#›</a:t>
             </a:fld>
@@ -1913,7 +1913,7 @@
     </p:spTree>
     <p:extLst>
       <p:ext uri="{BB962C8B-B14F-4D97-AF65-F5344CB8AC3E}">
-        <p14:creationId xmlns:p14="http://schemas.microsoft.com/office/powerpoint/2010/main" val="1005608574"/>
+        <p14:creationId xmlns:p14="http://schemas.microsoft.com/office/powerpoint/2010/main" val="1853718026"/>
       </p:ext>
     </p:extLst>
   </p:cSld>
@@ -1945,7 +1945,7 @@
           <p:cNvPr id="2" name="Title 1">
             <a:extLst>
               <a:ext uri="{FF2B5EF4-FFF2-40B4-BE49-F238E27FC236}">
-                <a16:creationId xmlns:a16="http://schemas.microsoft.com/office/drawing/2014/main" id="{5286EE9C-CC2A-60CA-D03C-3A3E7F285A63}"/>
+                <a16:creationId xmlns:a16="http://schemas.microsoft.com/office/drawing/2014/main" id="{0E04E419-A937-C703-1F3B-EB6F4B61F177}"/>
               </a:ext>
             </a:extLst>
           </p:cNvPr>
@@ -1973,7 +1973,7 @@
           <p:cNvPr id="3" name="Content Placeholder 2">
             <a:extLst>
               <a:ext uri="{FF2B5EF4-FFF2-40B4-BE49-F238E27FC236}">
-                <a16:creationId xmlns:a16="http://schemas.microsoft.com/office/drawing/2014/main" id="{E06CA9C7-9D7E-809B-DB1A-85E7796EAF85}"/>
+                <a16:creationId xmlns:a16="http://schemas.microsoft.com/office/drawing/2014/main" id="{3E310676-E73C-4396-E802-3FDCD3E8E197}"/>
               </a:ext>
             </a:extLst>
           </p:cNvPr>
@@ -2030,7 +2030,7 @@
           <p:cNvPr id="4" name="Date Placeholder 3">
             <a:extLst>
               <a:ext uri="{FF2B5EF4-FFF2-40B4-BE49-F238E27FC236}">
-                <a16:creationId xmlns:a16="http://schemas.microsoft.com/office/drawing/2014/main" id="{4E31C50E-6EC6-66A3-20BA-0B904071A306}"/>
+                <a16:creationId xmlns:a16="http://schemas.microsoft.com/office/drawing/2014/main" id="{DBA690C1-0506-24D0-86F4-01B2BFBC2CB7}"/>
               </a:ext>
             </a:extLst>
           </p:cNvPr>
@@ -2046,7 +2046,7 @@
           <a:bodyPr/>
           <a:lstStyle/>
           <a:p>
-            <a:fld id="{F977BB9B-F59E-4A9E-8FB1-55369D431D5A}" type="datetimeFigureOut">
+            <a:fld id="{1DDD3D51-C5CB-4127-A8E5-A017D0F1E954}" type="datetimeFigureOut">
               <a:rPr lang="en-US" smtClean="0"/>
               <a:t>21-Oct-26</a:t>
             </a:fld>
@@ -2059,7 +2059,7 @@
           <p:cNvPr id="5" name="Footer Placeholder 4">
             <a:extLst>
               <a:ext uri="{FF2B5EF4-FFF2-40B4-BE49-F238E27FC236}">
-                <a16:creationId xmlns:a16="http://schemas.microsoft.com/office/drawing/2014/main" id="{BEC36B94-B1F4-1218-3CC4-54B746BB35E0}"/>
+                <a16:creationId xmlns:a16="http://schemas.microsoft.com/office/drawing/2014/main" id="{7111B9DE-C44F-2A7C-F3F2-C5DF7A711752}"/>
               </a:ext>
             </a:extLst>
           </p:cNvPr>
@@ -2084,7 +2084,7 @@
           <p:cNvPr id="6" name="Slide Number Placeholder 5">
             <a:extLst>
               <a:ext uri="{FF2B5EF4-FFF2-40B4-BE49-F238E27FC236}">
-                <a16:creationId xmlns:a16="http://schemas.microsoft.com/office/drawing/2014/main" id="{E2D5212B-DD20-99CC-5030-2F54CEBBC46D}"/>
+                <a16:creationId xmlns:a16="http://schemas.microsoft.com/office/drawing/2014/main" id="{41108A14-9376-6F2A-8B46-02B2840797E5}"/>
               </a:ext>
             </a:extLst>
           </p:cNvPr>
@@ -2100,7 +2100,7 @@
           <a:bodyPr/>
           <a:lstStyle/>
           <a:p>
-            <a:fld id="{33AD01C5-AFAF-4916-9B99-98696E38DFA9}" type="slidenum">
+            <a:fld id="{F51E3BCC-0CEF-42DB-943A-D6620B5890DC}" type="slidenum">
               <a:rPr lang="en-US" smtClean="0"/>
               <a:t>‹#›</a:t>
             </a:fld>
@@ -2111,7 +2111,7 @@
     </p:spTree>
     <p:extLst>
       <p:ext uri="{BB962C8B-B14F-4D97-AF65-F5344CB8AC3E}">
-        <p14:creationId xmlns:p14="http://schemas.microsoft.com/office/powerpoint/2010/main" val="1739356486"/>
+        <p14:creationId xmlns:p14="http://schemas.microsoft.com/office/powerpoint/2010/main" val="3284903324"/>
       </p:ext>
     </p:extLst>
   </p:cSld>
@@ -2143,7 +2143,7 @@
           <p:cNvPr id="2" name="Title 1">
             <a:extLst>
               <a:ext uri="{FF2B5EF4-FFF2-40B4-BE49-F238E27FC236}">
-                <a16:creationId xmlns:a16="http://schemas.microsoft.com/office/drawing/2014/main" id="{C42CF65D-109C-9988-324A-7B89BCC0382E}"/>
+                <a16:creationId xmlns:a16="http://schemas.microsoft.com/office/drawing/2014/main" id="{7ABAD3C2-4221-A5A7-778F-E5A5B8C5AEC8}"/>
               </a:ext>
             </a:extLst>
           </p:cNvPr>
@@ -2180,7 +2180,7 @@
           <p:cNvPr id="3" name="Text Placeholder 2">
             <a:extLst>
               <a:ext uri="{FF2B5EF4-FFF2-40B4-BE49-F238E27FC236}">
-                <a16:creationId xmlns:a16="http://schemas.microsoft.com/office/drawing/2014/main" id="{0BFA8CB2-0658-E7A7-FA5E-F094C5B3CE56}"/>
+                <a16:creationId xmlns:a16="http://schemas.microsoft.com/office/drawing/2014/main" id="{F4F6BE16-2DB5-6961-BA5C-CF04E0EA7FA0}"/>
               </a:ext>
             </a:extLst>
           </p:cNvPr>
@@ -2305,7 +2305,7 @@
           <p:cNvPr id="4" name="Date Placeholder 3">
             <a:extLst>
               <a:ext uri="{FF2B5EF4-FFF2-40B4-BE49-F238E27FC236}">
-                <a16:creationId xmlns:a16="http://schemas.microsoft.com/office/drawing/2014/main" id="{57838071-B3E0-74C2-77F4-EA6DAFDB71EA}"/>
+                <a16:creationId xmlns:a16="http://schemas.microsoft.com/office/drawing/2014/main" id="{2C44DFD7-F4E2-1257-6F71-CDA413EFC555}"/>
               </a:ext>
             </a:extLst>
           </p:cNvPr>
@@ -2321,7 +2321,7 @@
           <a:bodyPr/>
           <a:lstStyle/>
           <a:p>
-            <a:fld id="{F977BB9B-F59E-4A9E-8FB1-55369D431D5A}" type="datetimeFigureOut">
+            <a:fld id="{1DDD3D51-C5CB-4127-A8E5-A017D0F1E954}" type="datetimeFigureOut">
               <a:rPr lang="en-US" smtClean="0"/>
               <a:t>21-Oct-26</a:t>
             </a:fld>
@@ -2334,7 +2334,7 @@
           <p:cNvPr id="5" name="Footer Placeholder 4">
             <a:extLst>
               <a:ext uri="{FF2B5EF4-FFF2-40B4-BE49-F238E27FC236}">
-                <a16:creationId xmlns:a16="http://schemas.microsoft.com/office/drawing/2014/main" id="{05848341-865B-6936-8D42-5F153B35D3CF}"/>
+                <a16:creationId xmlns:a16="http://schemas.microsoft.com/office/drawing/2014/main" id="{A9608F6C-2D09-46AC-02C7-DF8E8D7AB3D7}"/>
               </a:ext>
             </a:extLst>
           </p:cNvPr>
@@ -2359,7 +2359,7 @@
           <p:cNvPr id="6" name="Slide Number Placeholder 5">
             <a:extLst>
               <a:ext uri="{FF2B5EF4-FFF2-40B4-BE49-F238E27FC236}">
-                <a16:creationId xmlns:a16="http://schemas.microsoft.com/office/drawing/2014/main" id="{8AB38B9A-5C00-CD9E-FDFE-870FD4589122}"/>
+                <a16:creationId xmlns:a16="http://schemas.microsoft.com/office/drawing/2014/main" id="{81B97F74-DA83-BC72-7233-F567B81FD46C}"/>
               </a:ext>
             </a:extLst>
           </p:cNvPr>
@@ -2375,7 +2375,7 @@
           <a:bodyPr/>
           <a:lstStyle/>
           <a:p>
-            <a:fld id="{33AD01C5-AFAF-4916-9B99-98696E38DFA9}" type="slidenum">
+            <a:fld id="{F51E3BCC-0CEF-42DB-943A-D6620B5890DC}" type="slidenum">
               <a:rPr lang="en-US" smtClean="0"/>
               <a:t>‹#›</a:t>
             </a:fld>
@@ -2386,7 +2386,7 @@
     </p:spTree>
     <p:extLst>
       <p:ext uri="{BB962C8B-B14F-4D97-AF65-F5344CB8AC3E}">
-        <p14:creationId xmlns:p14="http://schemas.microsoft.com/office/powerpoint/2010/main" val="3577558485"/>
+        <p14:creationId xmlns:p14="http://schemas.microsoft.com/office/powerpoint/2010/main" val="3567252883"/>
       </p:ext>
     </p:extLst>
   </p:cSld>
@@ -2418,7 +2418,7 @@
           <p:cNvPr id="2" name="Title 1">
             <a:extLst>
               <a:ext uri="{FF2B5EF4-FFF2-40B4-BE49-F238E27FC236}">
-                <a16:creationId xmlns:a16="http://schemas.microsoft.com/office/drawing/2014/main" id="{513E581D-34B3-FBC0-6007-4A5869010D38}"/>
+                <a16:creationId xmlns:a16="http://schemas.microsoft.com/office/drawing/2014/main" id="{CADB3AD1-FA21-5E7A-6785-F38121DA5EAE}"/>
               </a:ext>
             </a:extLst>
           </p:cNvPr>
@@ -2446,7 +2446,7 @@
           <p:cNvPr id="3" name="Content Placeholder 2">
             <a:extLst>
               <a:ext uri="{FF2B5EF4-FFF2-40B4-BE49-F238E27FC236}">
-                <a16:creationId xmlns:a16="http://schemas.microsoft.com/office/drawing/2014/main" id="{1E61B942-BA0E-E097-AF40-0002E2D813F7}"/>
+                <a16:creationId xmlns:a16="http://schemas.microsoft.com/office/drawing/2014/main" id="{2A79CC31-D9A3-A331-7608-F2DEC678CA26}"/>
               </a:ext>
             </a:extLst>
           </p:cNvPr>
@@ -2508,7 +2508,7 @@
           <p:cNvPr id="4" name="Content Placeholder 3">
             <a:extLst>
               <a:ext uri="{FF2B5EF4-FFF2-40B4-BE49-F238E27FC236}">
-                <a16:creationId xmlns:a16="http://schemas.microsoft.com/office/drawing/2014/main" id="{6FAB22CA-F221-CC01-5915-529512FBE916}"/>
+                <a16:creationId xmlns:a16="http://schemas.microsoft.com/office/drawing/2014/main" id="{C0EE937B-96D7-EA27-5ACF-C8A4857A75C1}"/>
               </a:ext>
             </a:extLst>
           </p:cNvPr>
@@ -2570,7 +2570,7 @@
           <p:cNvPr id="5" name="Date Placeholder 4">
             <a:extLst>
               <a:ext uri="{FF2B5EF4-FFF2-40B4-BE49-F238E27FC236}">
-                <a16:creationId xmlns:a16="http://schemas.microsoft.com/office/drawing/2014/main" id="{CC68E463-5F9C-BE55-AD11-DA31A3445375}"/>
+                <a16:creationId xmlns:a16="http://schemas.microsoft.com/office/drawing/2014/main" id="{49C502F6-5DF8-3A6A-0CE4-686C815BE6B3}"/>
               </a:ext>
             </a:extLst>
           </p:cNvPr>
@@ -2586,7 +2586,7 @@
           <a:bodyPr/>
           <a:lstStyle/>
           <a:p>
-            <a:fld id="{F977BB9B-F59E-4A9E-8FB1-55369D431D5A}" type="datetimeFigureOut">
+            <a:fld id="{1DDD3D51-C5CB-4127-A8E5-A017D0F1E954}" type="datetimeFigureOut">
               <a:rPr lang="en-US" smtClean="0"/>
               <a:t>21-Oct-26</a:t>
             </a:fld>
@@ -2599,7 +2599,7 @@
           <p:cNvPr id="6" name="Footer Placeholder 5">
             <a:extLst>
               <a:ext uri="{FF2B5EF4-FFF2-40B4-BE49-F238E27FC236}">
-                <a16:creationId xmlns:a16="http://schemas.microsoft.com/office/drawing/2014/main" id="{37355E80-CF8A-7B54-217E-FD80102C2683}"/>
+                <a16:creationId xmlns:a16="http://schemas.microsoft.com/office/drawing/2014/main" id="{54ED277E-D6EC-6E82-68A9-49F96C5AE788}"/>
               </a:ext>
             </a:extLst>
           </p:cNvPr>
@@ -2624,7 +2624,7 @@
           <p:cNvPr id="7" name="Slide Number Placeholder 6">
             <a:extLst>
               <a:ext uri="{FF2B5EF4-FFF2-40B4-BE49-F238E27FC236}">
-                <a16:creationId xmlns:a16="http://schemas.microsoft.com/office/drawing/2014/main" id="{C6CFFE1C-7FAB-AF6C-724D-95B9DB2E1B04}"/>
+                <a16:creationId xmlns:a16="http://schemas.microsoft.com/office/drawing/2014/main" id="{52736754-3ECB-FD23-9A91-D8925BD3B1ED}"/>
               </a:ext>
             </a:extLst>
           </p:cNvPr>
@@ -2640,7 +2640,7 @@
           <a:bodyPr/>
           <a:lstStyle/>
           <a:p>
-            <a:fld id="{33AD01C5-AFAF-4916-9B99-98696E38DFA9}" type="slidenum">
+            <a:fld id="{F51E3BCC-0CEF-42DB-943A-D6620B5890DC}" type="slidenum">
               <a:rPr lang="en-US" smtClean="0"/>
               <a:t>‹#›</a:t>
             </a:fld>
@@ -2651,7 +2651,7 @@
     </p:spTree>
     <p:extLst>
       <p:ext uri="{BB962C8B-B14F-4D97-AF65-F5344CB8AC3E}">
-        <p14:creationId xmlns:p14="http://schemas.microsoft.com/office/powerpoint/2010/main" val="4001265344"/>
+        <p14:creationId xmlns:p14="http://schemas.microsoft.com/office/powerpoint/2010/main" val="3192595169"/>
       </p:ext>
     </p:extLst>
   </p:cSld>
@@ -2683,7 +2683,7 @@
           <p:cNvPr id="2" name="Title 1">
             <a:extLst>
               <a:ext uri="{FF2B5EF4-FFF2-40B4-BE49-F238E27FC236}">
-                <a16:creationId xmlns:a16="http://schemas.microsoft.com/office/drawing/2014/main" id="{780953E2-075C-100D-ECBE-CCBCDBC49F74}"/>
+                <a16:creationId xmlns:a16="http://schemas.microsoft.com/office/drawing/2014/main" id="{9E68512E-CE93-5B37-5C4D-6BF0142EC96C}"/>
               </a:ext>
             </a:extLst>
           </p:cNvPr>
@@ -2716,7 +2716,7 @@
           <p:cNvPr id="3" name="Text Placeholder 2">
             <a:extLst>
               <a:ext uri="{FF2B5EF4-FFF2-40B4-BE49-F238E27FC236}">
-                <a16:creationId xmlns:a16="http://schemas.microsoft.com/office/drawing/2014/main" id="{1AC260E5-BEAD-0F7B-2C32-8179943735C8}"/>
+                <a16:creationId xmlns:a16="http://schemas.microsoft.com/office/drawing/2014/main" id="{C12595C9-1C0C-6AA3-DD5B-5E128A99C444}"/>
               </a:ext>
             </a:extLst>
           </p:cNvPr>
@@ -2787,7 +2787,7 @@
           <p:cNvPr id="4" name="Content Placeholder 3">
             <a:extLst>
               <a:ext uri="{FF2B5EF4-FFF2-40B4-BE49-F238E27FC236}">
-                <a16:creationId xmlns:a16="http://schemas.microsoft.com/office/drawing/2014/main" id="{EED2ED84-6018-F0F5-492F-80BF572C8B9E}"/>
+                <a16:creationId xmlns:a16="http://schemas.microsoft.com/office/drawing/2014/main" id="{C8505019-9DDF-07F6-3DA9-690A5C6A5D15}"/>
               </a:ext>
             </a:extLst>
           </p:cNvPr>
@@ -2849,7 +2849,7 @@
           <p:cNvPr id="5" name="Text Placeholder 4">
             <a:extLst>
               <a:ext uri="{FF2B5EF4-FFF2-40B4-BE49-F238E27FC236}">
-                <a16:creationId xmlns:a16="http://schemas.microsoft.com/office/drawing/2014/main" id="{68625864-3AEE-6A90-E134-12E93CCC5484}"/>
+                <a16:creationId xmlns:a16="http://schemas.microsoft.com/office/drawing/2014/main" id="{11A372F3-79E0-46E3-80F8-284D9BCB53F6}"/>
               </a:ext>
             </a:extLst>
           </p:cNvPr>
@@ -2920,7 +2920,7 @@
           <p:cNvPr id="6" name="Content Placeholder 5">
             <a:extLst>
               <a:ext uri="{FF2B5EF4-FFF2-40B4-BE49-F238E27FC236}">
-                <a16:creationId xmlns:a16="http://schemas.microsoft.com/office/drawing/2014/main" id="{AE3B42E4-9EFC-418D-6DE8-1064F49ADAB2}"/>
+                <a16:creationId xmlns:a16="http://schemas.microsoft.com/office/drawing/2014/main" id="{B1803263-44CC-1EAF-E012-900F55CC0CF8}"/>
               </a:ext>
             </a:extLst>
           </p:cNvPr>
@@ -2982,7 +2982,7 @@
           <p:cNvPr id="7" name="Date Placeholder 6">
             <a:extLst>
               <a:ext uri="{FF2B5EF4-FFF2-40B4-BE49-F238E27FC236}">
-                <a16:creationId xmlns:a16="http://schemas.microsoft.com/office/drawing/2014/main" id="{3CDD7CF9-14D9-6848-0501-7613350C68DA}"/>
+                <a16:creationId xmlns:a16="http://schemas.microsoft.com/office/drawing/2014/main" id="{0A670A6E-E36D-6D8D-5F66-E338DD172B42}"/>
               </a:ext>
             </a:extLst>
           </p:cNvPr>
@@ -2998,7 +2998,7 @@
           <a:bodyPr/>
           <a:lstStyle/>
           <a:p>
-            <a:fld id="{F977BB9B-F59E-4A9E-8FB1-55369D431D5A}" type="datetimeFigureOut">
+            <a:fld id="{1DDD3D51-C5CB-4127-A8E5-A017D0F1E954}" type="datetimeFigureOut">
               <a:rPr lang="en-US" smtClean="0"/>
               <a:t>21-Oct-26</a:t>
             </a:fld>
@@ -3011,7 +3011,7 @@
           <p:cNvPr id="8" name="Footer Placeholder 7">
             <a:extLst>
               <a:ext uri="{FF2B5EF4-FFF2-40B4-BE49-F238E27FC236}">
-                <a16:creationId xmlns:a16="http://schemas.microsoft.com/office/drawing/2014/main" id="{EA84215A-9953-244E-512D-487F9B3345C9}"/>
+                <a16:creationId xmlns:a16="http://schemas.microsoft.com/office/drawing/2014/main" id="{5E64417A-1DA2-BBB0-245A-41EC518CE7ED}"/>
               </a:ext>
             </a:extLst>
           </p:cNvPr>
@@ -3036,7 +3036,7 @@
           <p:cNvPr id="9" name="Slide Number Placeholder 8">
             <a:extLst>
               <a:ext uri="{FF2B5EF4-FFF2-40B4-BE49-F238E27FC236}">
-                <a16:creationId xmlns:a16="http://schemas.microsoft.com/office/drawing/2014/main" id="{239CB91F-9032-79D9-B461-08121F02B698}"/>
+                <a16:creationId xmlns:a16="http://schemas.microsoft.com/office/drawing/2014/main" id="{BED7923A-9337-D8E2-8741-A6403E6DBF04}"/>
               </a:ext>
             </a:extLst>
           </p:cNvPr>
@@ -3052,7 +3052,7 @@
           <a:bodyPr/>
           <a:lstStyle/>
           <a:p>
-            <a:fld id="{33AD01C5-AFAF-4916-9B99-98696E38DFA9}" type="slidenum">
+            <a:fld id="{F51E3BCC-0CEF-42DB-943A-D6620B5890DC}" type="slidenum">
               <a:rPr lang="en-US" smtClean="0"/>
               <a:t>‹#›</a:t>
             </a:fld>
@@ -3063,7 +3063,7 @@
     </p:spTree>
     <p:extLst>
       <p:ext uri="{BB962C8B-B14F-4D97-AF65-F5344CB8AC3E}">
-        <p14:creationId xmlns:p14="http://schemas.microsoft.com/office/powerpoint/2010/main" val="2956858254"/>
+        <p14:creationId xmlns:p14="http://schemas.microsoft.com/office/powerpoint/2010/main" val="1698377077"/>
       </p:ext>
     </p:extLst>
   </p:cSld>
@@ -3095,7 +3095,7 @@
           <p:cNvPr id="2" name="Title 1">
             <a:extLst>
               <a:ext uri="{FF2B5EF4-FFF2-40B4-BE49-F238E27FC236}">
-                <a16:creationId xmlns:a16="http://schemas.microsoft.com/office/drawing/2014/main" id="{3F4D9FCB-D4C8-3C8B-3E38-4EAB1C719FBB}"/>
+                <a16:creationId xmlns:a16="http://schemas.microsoft.com/office/drawing/2014/main" id="{6375890A-11C8-326D-A751-6EF76506669B}"/>
               </a:ext>
             </a:extLst>
           </p:cNvPr>
@@ -3123,7 +3123,7 @@
           <p:cNvPr id="3" name="Date Placeholder 2">
             <a:extLst>
               <a:ext uri="{FF2B5EF4-FFF2-40B4-BE49-F238E27FC236}">
-                <a16:creationId xmlns:a16="http://schemas.microsoft.com/office/drawing/2014/main" id="{2D3EADB1-00AC-1109-3149-0990BCA7F397}"/>
+                <a16:creationId xmlns:a16="http://schemas.microsoft.com/office/drawing/2014/main" id="{D5624F41-8DD9-0708-06FE-4D00C3360DFA}"/>
               </a:ext>
             </a:extLst>
           </p:cNvPr>
@@ -3139,7 +3139,7 @@
           <a:bodyPr/>
           <a:lstStyle/>
           <a:p>
-            <a:fld id="{F977BB9B-F59E-4A9E-8FB1-55369D431D5A}" type="datetimeFigureOut">
+            <a:fld id="{1DDD3D51-C5CB-4127-A8E5-A017D0F1E954}" type="datetimeFigureOut">
               <a:rPr lang="en-US" smtClean="0"/>
               <a:t>21-Oct-26</a:t>
             </a:fld>
@@ -3152,7 +3152,7 @@
           <p:cNvPr id="4" name="Footer Placeholder 3">
             <a:extLst>
               <a:ext uri="{FF2B5EF4-FFF2-40B4-BE49-F238E27FC236}">
-                <a16:creationId xmlns:a16="http://schemas.microsoft.com/office/drawing/2014/main" id="{072F0812-F343-BB2E-42A2-49074D80A221}"/>
+                <a16:creationId xmlns:a16="http://schemas.microsoft.com/office/drawing/2014/main" id="{F8B692C9-96A0-878C-2880-E9CD1EEA8B61}"/>
               </a:ext>
             </a:extLst>
           </p:cNvPr>
@@ -3177,7 +3177,7 @@
           <p:cNvPr id="5" name="Slide Number Placeholder 4">
             <a:extLst>
               <a:ext uri="{FF2B5EF4-FFF2-40B4-BE49-F238E27FC236}">
-                <a16:creationId xmlns:a16="http://schemas.microsoft.com/office/drawing/2014/main" id="{34DA29D3-CB04-9087-BF5B-2BEFA89DBC59}"/>
+                <a16:creationId xmlns:a16="http://schemas.microsoft.com/office/drawing/2014/main" id="{CE0C107A-7936-301A-BD27-51F974500209}"/>
               </a:ext>
             </a:extLst>
           </p:cNvPr>
@@ -3193,7 +3193,7 @@
           <a:bodyPr/>
           <a:lstStyle/>
           <a:p>
-            <a:fld id="{33AD01C5-AFAF-4916-9B99-98696E38DFA9}" type="slidenum">
+            <a:fld id="{F51E3BCC-0CEF-42DB-943A-D6620B5890DC}" type="slidenum">
               <a:rPr lang="en-US" smtClean="0"/>
               <a:t>‹#›</a:t>
             </a:fld>
@@ -3204,7 +3204,7 @@
     </p:spTree>
     <p:extLst>
       <p:ext uri="{BB962C8B-B14F-4D97-AF65-F5344CB8AC3E}">
-        <p14:creationId xmlns:p14="http://schemas.microsoft.com/office/powerpoint/2010/main" val="1224810529"/>
+        <p14:creationId xmlns:p14="http://schemas.microsoft.com/office/powerpoint/2010/main" val="3063488348"/>
       </p:ext>
     </p:extLst>
   </p:cSld>
@@ -3236,7 +3236,7 @@
           <p:cNvPr id="2" name="Date Placeholder 1">
             <a:extLst>
               <a:ext uri="{FF2B5EF4-FFF2-40B4-BE49-F238E27FC236}">
-                <a16:creationId xmlns:a16="http://schemas.microsoft.com/office/drawing/2014/main" id="{C7E9A758-EBBE-5C67-A5E5-1922ACE3B52E}"/>
+                <a16:creationId xmlns:a16="http://schemas.microsoft.com/office/drawing/2014/main" id="{2848FDB2-F7C1-9F0D-C04F-30A461A2FB86}"/>
               </a:ext>
             </a:extLst>
           </p:cNvPr>
@@ -3252,7 +3252,7 @@
           <a:bodyPr/>
           <a:lstStyle/>
           <a:p>
-            <a:fld id="{F977BB9B-F59E-4A9E-8FB1-55369D431D5A}" type="datetimeFigureOut">
+            <a:fld id="{1DDD3D51-C5CB-4127-A8E5-A017D0F1E954}" type="datetimeFigureOut">
               <a:rPr lang="en-US" smtClean="0"/>
               <a:t>21-Oct-26</a:t>
             </a:fld>
@@ -3265,7 +3265,7 @@
           <p:cNvPr id="3" name="Footer Placeholder 2">
             <a:extLst>
               <a:ext uri="{FF2B5EF4-FFF2-40B4-BE49-F238E27FC236}">
-                <a16:creationId xmlns:a16="http://schemas.microsoft.com/office/drawing/2014/main" id="{256DC41D-AA4B-C701-B569-05E5BAA55D36}"/>
+                <a16:creationId xmlns:a16="http://schemas.microsoft.com/office/drawing/2014/main" id="{61302A42-7010-2842-3F9C-F21444295BDD}"/>
               </a:ext>
             </a:extLst>
           </p:cNvPr>
@@ -3290,7 +3290,7 @@
           <p:cNvPr id="4" name="Slide Number Placeholder 3">
             <a:extLst>
               <a:ext uri="{FF2B5EF4-FFF2-40B4-BE49-F238E27FC236}">
-                <a16:creationId xmlns:a16="http://schemas.microsoft.com/office/drawing/2014/main" id="{A67859AE-FBAE-85D8-0083-018E7122CF79}"/>
+                <a16:creationId xmlns:a16="http://schemas.microsoft.com/office/drawing/2014/main" id="{27953CE3-394C-1E3C-6B9E-5DEAA8F10941}"/>
               </a:ext>
             </a:extLst>
           </p:cNvPr>
@@ -3306,7 +3306,7 @@
           <a:bodyPr/>
           <a:lstStyle/>
           <a:p>
-            <a:fld id="{33AD01C5-AFAF-4916-9B99-98696E38DFA9}" type="slidenum">
+            <a:fld id="{F51E3BCC-0CEF-42DB-943A-D6620B5890DC}" type="slidenum">
               <a:rPr lang="en-US" smtClean="0"/>
               <a:t>‹#›</a:t>
             </a:fld>
@@ -3317,7 +3317,7 @@
     </p:spTree>
     <p:extLst>
       <p:ext uri="{BB962C8B-B14F-4D97-AF65-F5344CB8AC3E}">
-        <p14:creationId xmlns:p14="http://schemas.microsoft.com/office/powerpoint/2010/main" val="1446158179"/>
+        <p14:creationId xmlns:p14="http://schemas.microsoft.com/office/powerpoint/2010/main" val="1828197115"/>
       </p:ext>
     </p:extLst>
   </p:cSld>
@@ -3349,7 +3349,7 @@
           <p:cNvPr id="2" name="Title 1">
             <a:extLst>
               <a:ext uri="{FF2B5EF4-FFF2-40B4-BE49-F238E27FC236}">
-                <a16:creationId xmlns:a16="http://schemas.microsoft.com/office/drawing/2014/main" id="{8EA2B336-590C-847B-A770-0DD65FBC83D9}"/>
+                <a16:creationId xmlns:a16="http://schemas.microsoft.com/office/drawing/2014/main" id="{CB07A496-7753-C85D-BF4A-D8DD4DF9EF2B}"/>
               </a:ext>
             </a:extLst>
           </p:cNvPr>
@@ -3386,7 +3386,7 @@
           <p:cNvPr id="3" name="Content Placeholder 2">
             <a:extLst>
               <a:ext uri="{FF2B5EF4-FFF2-40B4-BE49-F238E27FC236}">
-                <a16:creationId xmlns:a16="http://schemas.microsoft.com/office/drawing/2014/main" id="{44321C7E-333D-6C0D-C946-292A67BD15AA}"/>
+                <a16:creationId xmlns:a16="http://schemas.microsoft.com/office/drawing/2014/main" id="{8097B6E5-A8C5-7047-92DF-3ECB319324AB}"/>
               </a:ext>
             </a:extLst>
           </p:cNvPr>
@@ -3476,7 +3476,7 @@
           <p:cNvPr id="4" name="Text Placeholder 3">
             <a:extLst>
               <a:ext uri="{FF2B5EF4-FFF2-40B4-BE49-F238E27FC236}">
-                <a16:creationId xmlns:a16="http://schemas.microsoft.com/office/drawing/2014/main" id="{C31E83EF-7B64-03FF-BE37-4ED12AEE16D5}"/>
+                <a16:creationId xmlns:a16="http://schemas.microsoft.com/office/drawing/2014/main" id="{036C3B67-CBD7-6B32-CF17-C9C7EA411CC8}"/>
               </a:ext>
             </a:extLst>
           </p:cNvPr>
@@ -3547,7 +3547,7 @@
           <p:cNvPr id="5" name="Date Placeholder 4">
             <a:extLst>
               <a:ext uri="{FF2B5EF4-FFF2-40B4-BE49-F238E27FC236}">
-                <a16:creationId xmlns:a16="http://schemas.microsoft.com/office/drawing/2014/main" id="{104FBF43-470E-470E-8DAD-6755AB9301CA}"/>
+                <a16:creationId xmlns:a16="http://schemas.microsoft.com/office/drawing/2014/main" id="{69AF81FF-F977-6D83-1268-CBEBC2721E12}"/>
               </a:ext>
             </a:extLst>
           </p:cNvPr>
@@ -3563,7 +3563,7 @@
           <a:bodyPr/>
           <a:lstStyle/>
           <a:p>
-            <a:fld id="{F977BB9B-F59E-4A9E-8FB1-55369D431D5A}" type="datetimeFigureOut">
+            <a:fld id="{1DDD3D51-C5CB-4127-A8E5-A017D0F1E954}" type="datetimeFigureOut">
               <a:rPr lang="en-US" smtClean="0"/>
               <a:t>21-Oct-26</a:t>
             </a:fld>
@@ -3576,7 +3576,7 @@
           <p:cNvPr id="6" name="Footer Placeholder 5">
             <a:extLst>
               <a:ext uri="{FF2B5EF4-FFF2-40B4-BE49-F238E27FC236}">
-                <a16:creationId xmlns:a16="http://schemas.microsoft.com/office/drawing/2014/main" id="{994EAA56-C664-00AC-B607-C045BDA0325A}"/>
+                <a16:creationId xmlns:a16="http://schemas.microsoft.com/office/drawing/2014/main" id="{E8BEBBE0-D8A5-87BB-3157-89C51F90CE21}"/>
               </a:ext>
             </a:extLst>
           </p:cNvPr>
@@ -3601,7 +3601,7 @@
           <p:cNvPr id="7" name="Slide Number Placeholder 6">
             <a:extLst>
               <a:ext uri="{FF2B5EF4-FFF2-40B4-BE49-F238E27FC236}">
-                <a16:creationId xmlns:a16="http://schemas.microsoft.com/office/drawing/2014/main" id="{0B24CF79-48AF-CE87-A7BA-1AAC3D7DD970}"/>
+                <a16:creationId xmlns:a16="http://schemas.microsoft.com/office/drawing/2014/main" id="{1E4D9A4C-D128-5049-D696-32FBCEBD893F}"/>
               </a:ext>
             </a:extLst>
           </p:cNvPr>
@@ -3617,7 +3617,7 @@
           <a:bodyPr/>
           <a:lstStyle/>
           <a:p>
-            <a:fld id="{33AD01C5-AFAF-4916-9B99-98696E38DFA9}" type="slidenum">
+            <a:fld id="{F51E3BCC-0CEF-42DB-943A-D6620B5890DC}" type="slidenum">
               <a:rPr lang="en-US" smtClean="0"/>
               <a:t>‹#›</a:t>
             </a:fld>
@@ -3628,7 +3628,7 @@
     </p:spTree>
     <p:extLst>
       <p:ext uri="{BB962C8B-B14F-4D97-AF65-F5344CB8AC3E}">
-        <p14:creationId xmlns:p14="http://schemas.microsoft.com/office/powerpoint/2010/main" val="1787002630"/>
+        <p14:creationId xmlns:p14="http://schemas.microsoft.com/office/powerpoint/2010/main" val="3032465659"/>
       </p:ext>
     </p:extLst>
   </p:cSld>
@@ -3660,7 +3660,7 @@
           <p:cNvPr id="2" name="Title 1">
             <a:extLst>
               <a:ext uri="{FF2B5EF4-FFF2-40B4-BE49-F238E27FC236}">
-                <a16:creationId xmlns:a16="http://schemas.microsoft.com/office/drawing/2014/main" id="{C35744EE-71FE-10C9-0629-FE4B20E1D89D}"/>
+                <a16:creationId xmlns:a16="http://schemas.microsoft.com/office/drawing/2014/main" id="{246FCB07-4AE5-7D31-AC36-6E89646AB10E}"/>
               </a:ext>
             </a:extLst>
           </p:cNvPr>
@@ -3697,7 +3697,7 @@
           <p:cNvPr id="3" name="Picture Placeholder 2">
             <a:extLst>
               <a:ext uri="{FF2B5EF4-FFF2-40B4-BE49-F238E27FC236}">
-                <a16:creationId xmlns:a16="http://schemas.microsoft.com/office/drawing/2014/main" id="{BA24E806-F371-396E-C40C-70CAD029E7E8}"/>
+                <a16:creationId xmlns:a16="http://schemas.microsoft.com/office/drawing/2014/main" id="{712594E8-177E-BABE-F1BA-5FCA9AEE5A73}"/>
               </a:ext>
             </a:extLst>
           </p:cNvPr>
@@ -3764,7 +3764,7 @@
           <p:cNvPr id="4" name="Text Placeholder 3">
             <a:extLst>
               <a:ext uri="{FF2B5EF4-FFF2-40B4-BE49-F238E27FC236}">
-                <a16:creationId xmlns:a16="http://schemas.microsoft.com/office/drawing/2014/main" id="{2FDABEDE-EA9E-089C-696A-311F24ACDA7E}"/>
+                <a16:creationId xmlns:a16="http://schemas.microsoft.com/office/drawing/2014/main" id="{5D875790-1960-1651-E671-1B44A4ADE516}"/>
               </a:ext>
             </a:extLst>
           </p:cNvPr>
@@ -3835,7 +3835,7 @@
           <p:cNvPr id="5" name="Date Placeholder 4">
             <a:extLst>
               <a:ext uri="{FF2B5EF4-FFF2-40B4-BE49-F238E27FC236}">
-                <a16:creationId xmlns:a16="http://schemas.microsoft.com/office/drawing/2014/main" id="{7F56C850-3A71-A43E-558D-DC1257C50043}"/>
+                <a16:creationId xmlns:a16="http://schemas.microsoft.com/office/drawing/2014/main" id="{8442B624-B60D-1C74-91B4-E4555194BAA2}"/>
               </a:ext>
             </a:extLst>
           </p:cNvPr>
@@ -3851,7 +3851,7 @@
           <a:bodyPr/>
           <a:lstStyle/>
           <a:p>
-            <a:fld id="{F977BB9B-F59E-4A9E-8FB1-55369D431D5A}" type="datetimeFigureOut">
+            <a:fld id="{1DDD3D51-C5CB-4127-A8E5-A017D0F1E954}" type="datetimeFigureOut">
               <a:rPr lang="en-US" smtClean="0"/>
               <a:t>21-Oct-26</a:t>
             </a:fld>
@@ -3864,7 +3864,7 @@
           <p:cNvPr id="6" name="Footer Placeholder 5">
             <a:extLst>
               <a:ext uri="{FF2B5EF4-FFF2-40B4-BE49-F238E27FC236}">
-                <a16:creationId xmlns:a16="http://schemas.microsoft.com/office/drawing/2014/main" id="{FB546816-17BA-6035-3032-13E01A9806A6}"/>
+                <a16:creationId xmlns:a16="http://schemas.microsoft.com/office/drawing/2014/main" id="{64849259-421B-9A6B-AA9F-FE11CA414B28}"/>
               </a:ext>
             </a:extLst>
           </p:cNvPr>
@@ -3889,7 +3889,7 @@
           <p:cNvPr id="7" name="Slide Number Placeholder 6">
             <a:extLst>
               <a:ext uri="{FF2B5EF4-FFF2-40B4-BE49-F238E27FC236}">
-                <a16:creationId xmlns:a16="http://schemas.microsoft.com/office/drawing/2014/main" id="{972947D3-CD26-F455-8731-894572C20910}"/>
+                <a16:creationId xmlns:a16="http://schemas.microsoft.com/office/drawing/2014/main" id="{52B121C4-049A-3038-FBE2-CD6A327D8D35}"/>
               </a:ext>
             </a:extLst>
           </p:cNvPr>
@@ -3905,7 +3905,7 @@
           <a:bodyPr/>
           <a:lstStyle/>
           <a:p>
-            <a:fld id="{33AD01C5-AFAF-4916-9B99-98696E38DFA9}" type="slidenum">
+            <a:fld id="{F51E3BCC-0CEF-42DB-943A-D6620B5890DC}" type="slidenum">
               <a:rPr lang="en-US" smtClean="0"/>
               <a:t>‹#›</a:t>
             </a:fld>
@@ -3916,7 +3916,7 @@
     </p:spTree>
     <p:extLst>
       <p:ext uri="{BB962C8B-B14F-4D97-AF65-F5344CB8AC3E}">
-        <p14:creationId xmlns:p14="http://schemas.microsoft.com/office/powerpoint/2010/main" val="1119204422"/>
+        <p14:creationId xmlns:p14="http://schemas.microsoft.com/office/powerpoint/2010/main" val="1617702828"/>
       </p:ext>
     </p:extLst>
   </p:cSld>
@@ -3953,7 +3953,7 @@
           <p:cNvPr id="2" name="Title Placeholder 1">
             <a:extLst>
               <a:ext uri="{FF2B5EF4-FFF2-40B4-BE49-F238E27FC236}">
-                <a16:creationId xmlns:a16="http://schemas.microsoft.com/office/drawing/2014/main" id="{041228CA-6AC1-6B3D-1D0A-E085BA85447D}"/>
+                <a16:creationId xmlns:a16="http://schemas.microsoft.com/office/drawing/2014/main" id="{06162273-91AE-0598-901B-CB4CB4F74AAF}"/>
               </a:ext>
             </a:extLst>
           </p:cNvPr>
@@ -3991,7 +3991,7 @@
           <p:cNvPr id="3" name="Text Placeholder 2">
             <a:extLst>
               <a:ext uri="{FF2B5EF4-FFF2-40B4-BE49-F238E27FC236}">
-                <a16:creationId xmlns:a16="http://schemas.microsoft.com/office/drawing/2014/main" id="{F6A4C14B-E28D-2474-FC25-933CA066D487}"/>
+                <a16:creationId xmlns:a16="http://schemas.microsoft.com/office/drawing/2014/main" id="{3FE7C8A0-2103-DC5A-4892-F2139F99A05F}"/>
               </a:ext>
             </a:extLst>
           </p:cNvPr>
@@ -4058,7 +4058,7 @@
           <p:cNvPr id="4" name="Date Placeholder 3">
             <a:extLst>
               <a:ext uri="{FF2B5EF4-FFF2-40B4-BE49-F238E27FC236}">
-                <a16:creationId xmlns:a16="http://schemas.microsoft.com/office/drawing/2014/main" id="{B76F1D42-9A31-830E-127A-7FAF54108279}"/>
+                <a16:creationId xmlns:a16="http://schemas.microsoft.com/office/drawing/2014/main" id="{E215E4B3-0217-E58C-53DA-1F529086331D}"/>
               </a:ext>
             </a:extLst>
           </p:cNvPr>
@@ -4092,7 +4092,7 @@
             </a:lvl1pPr>
           </a:lstStyle>
           <a:p>
-            <a:fld id="{F977BB9B-F59E-4A9E-8FB1-55369D431D5A}" type="datetimeFigureOut">
+            <a:fld id="{1DDD3D51-C5CB-4127-A8E5-A017D0F1E954}" type="datetimeFigureOut">
               <a:rPr lang="en-US" smtClean="0"/>
               <a:t>21-Oct-26</a:t>
             </a:fld>
@@ -4105,7 +4105,7 @@
           <p:cNvPr id="5" name="Footer Placeholder 4">
             <a:extLst>
               <a:ext uri="{FF2B5EF4-FFF2-40B4-BE49-F238E27FC236}">
-                <a16:creationId xmlns:a16="http://schemas.microsoft.com/office/drawing/2014/main" id="{B4E27012-5408-EEDF-4CFB-11192401694B}"/>
+                <a16:creationId xmlns:a16="http://schemas.microsoft.com/office/drawing/2014/main" id="{35BAB711-8980-E2E3-F834-9D984F9841EE}"/>
               </a:ext>
             </a:extLst>
           </p:cNvPr>
@@ -4148,7 +4148,7 @@
           <p:cNvPr id="6" name="Slide Number Placeholder 5">
             <a:extLst>
               <a:ext uri="{FF2B5EF4-FFF2-40B4-BE49-F238E27FC236}">
-                <a16:creationId xmlns:a16="http://schemas.microsoft.com/office/drawing/2014/main" id="{8DC46A17-C3AD-E7AC-2793-F21E59C702F1}"/>
+                <a16:creationId xmlns:a16="http://schemas.microsoft.com/office/drawing/2014/main" id="{BE2034C7-C38F-002D-F192-7BF6DACE678F}"/>
               </a:ext>
             </a:extLst>
           </p:cNvPr>
@@ -4182,7 +4182,7 @@
             </a:lvl1pPr>
           </a:lstStyle>
           <a:p>
-            <a:fld id="{33AD01C5-AFAF-4916-9B99-98696E38DFA9}" type="slidenum">
+            <a:fld id="{F51E3BCC-0CEF-42DB-943A-D6620B5890DC}" type="slidenum">
               <a:rPr lang="en-US" smtClean="0"/>
               <a:t>‹#›</a:t>
             </a:fld>
@@ -4193,7 +4193,7 @@
     </p:spTree>
     <p:extLst>
       <p:ext uri="{BB962C8B-B14F-4D97-AF65-F5344CB8AC3E}">
-        <p14:creationId xmlns:p14="http://schemas.microsoft.com/office/powerpoint/2010/main" val="448161332"/>
+        <p14:creationId xmlns:p14="http://schemas.microsoft.com/office/powerpoint/2010/main" val="1497404527"/>
       </p:ext>
     </p:extLst>
   </p:cSld>
@@ -4517,7 +4517,7 @@
           <p:cNvPr id="2" name="Title 1">
             <a:extLst>
               <a:ext uri="{FF2B5EF4-FFF2-40B4-BE49-F238E27FC236}">
-                <a16:creationId xmlns:a16="http://schemas.microsoft.com/office/drawing/2014/main" id="{10BFD66C-E4C6-1DF2-60A4-9F6EF6A940E8}"/>
+                <a16:creationId xmlns:a16="http://schemas.microsoft.com/office/drawing/2014/main" id="{622F4287-6535-7928-3221-B9B74CB66E5C}"/>
               </a:ext>
             </a:extLst>
           </p:cNvPr>
@@ -4545,7 +4545,7 @@
           <p:cNvPr id="3" name="Text Placeholder 2">
             <a:extLst>
               <a:ext uri="{FF2B5EF4-FFF2-40B4-BE49-F238E27FC236}">
-                <a16:creationId xmlns:a16="http://schemas.microsoft.com/office/drawing/2014/main" id="{8D554CB2-BA58-C976-78DC-496C3E26F029}"/>
+                <a16:creationId xmlns:a16="http://schemas.microsoft.com/office/drawing/2014/main" id="{C70AAD12-A91C-868B-5320-59B609067022}"/>
               </a:ext>
             </a:extLst>
           </p:cNvPr>
@@ -4571,7 +4571,7 @@
     </p:spTree>
     <p:extLst>
       <p:ext uri="{BB962C8B-B14F-4D97-AF65-F5344CB8AC3E}">
-        <p14:creationId xmlns:p14="http://schemas.microsoft.com/office/powerpoint/2010/main" val="2258425720"/>
+        <p14:creationId xmlns:p14="http://schemas.microsoft.com/office/powerpoint/2010/main" val="1237191225"/>
       </p:ext>
     </p:extLst>
   </p:cSld>
@@ -4603,7 +4603,7 @@
           <p:cNvPr id="2" name="Title 1">
             <a:extLst>
               <a:ext uri="{FF2B5EF4-FFF2-40B4-BE49-F238E27FC236}">
-                <a16:creationId xmlns:a16="http://schemas.microsoft.com/office/drawing/2014/main" id="{6531497A-33BC-FBBE-FBBA-B25E9CE949A1}"/>
+                <a16:creationId xmlns:a16="http://schemas.microsoft.com/office/drawing/2014/main" id="{5584B10F-8A6B-AB54-35C0-784F10E2E11F}"/>
               </a:ext>
             </a:extLst>
           </p:cNvPr>
@@ -4631,7 +4631,7 @@
           <p:cNvPr id="3" name="Text Placeholder 2">
             <a:extLst>
               <a:ext uri="{FF2B5EF4-FFF2-40B4-BE49-F238E27FC236}">
-                <a16:creationId xmlns:a16="http://schemas.microsoft.com/office/drawing/2014/main" id="{B77186CD-02B6-082C-C5A5-1CCCC7559534}"/>
+                <a16:creationId xmlns:a16="http://schemas.microsoft.com/office/drawing/2014/main" id="{0206717D-C045-FD38-CA74-66686D1B6101}"/>
               </a:ext>
             </a:extLst>
           </p:cNvPr>
@@ -4660,7 +4660,7 @@
             <a:hlinkClick r:id="rId3" action="ppaction://hlinksldjump"/>
             <a:extLst>
               <a:ext uri="{FF2B5EF4-FFF2-40B4-BE49-F238E27FC236}">
-                <a16:creationId xmlns:a16="http://schemas.microsoft.com/office/drawing/2014/main" id="{2C946A13-11DE-ED7A-ED12-290A866D1824}"/>
+                <a16:creationId xmlns:a16="http://schemas.microsoft.com/office/drawing/2014/main" id="{0EBE6480-6046-7814-E37D-DCC6FB7D107F}"/>
               </a:ext>
             </a:extLst>
           </p:cNvPr>
@@ -4710,7 +4710,7 @@
             <a:hlinkClick r:id="" action="ppaction://hlinkshowjump?jump=lastslide"/>
             <a:extLst>
               <a:ext uri="{FF2B5EF4-FFF2-40B4-BE49-F238E27FC236}">
-                <a16:creationId xmlns:a16="http://schemas.microsoft.com/office/drawing/2014/main" id="{06B924A9-45E7-B3D2-B900-7035C82A7F2C}"/>
+                <a16:creationId xmlns:a16="http://schemas.microsoft.com/office/drawing/2014/main" id="{E5B4A585-854C-E2B7-91DD-41F891554D12}"/>
               </a:ext>
             </a:extLst>
           </p:cNvPr>
@@ -4757,7 +4757,7 @@
     </p:spTree>
     <p:extLst>
       <p:ext uri="{BB962C8B-B14F-4D97-AF65-F5344CB8AC3E}">
-        <p14:creationId xmlns:p14="http://schemas.microsoft.com/office/powerpoint/2010/main" val="2891365247"/>
+        <p14:creationId xmlns:p14="http://schemas.microsoft.com/office/powerpoint/2010/main" val="795722134"/>
       </p:ext>
     </p:extLst>
   </p:cSld>
@@ -4789,7 +4789,7 @@
           <p:cNvPr id="2" name="Title 1">
             <a:extLst>
               <a:ext uri="{FF2B5EF4-FFF2-40B4-BE49-F238E27FC236}">
-                <a16:creationId xmlns:a16="http://schemas.microsoft.com/office/drawing/2014/main" id="{835EBE39-6C85-5E2C-6BFA-7CCAA0818F5D}"/>
+                <a16:creationId xmlns:a16="http://schemas.microsoft.com/office/drawing/2014/main" id="{6B76C4B7-7EB3-A35D-E3D8-CD5B3A82BAA4}"/>
               </a:ext>
             </a:extLst>
           </p:cNvPr>
@@ -4817,7 +4817,7 @@
           <p:cNvPr id="3" name="Text Placeholder 2">
             <a:extLst>
               <a:ext uri="{FF2B5EF4-FFF2-40B4-BE49-F238E27FC236}">
-                <a16:creationId xmlns:a16="http://schemas.microsoft.com/office/drawing/2014/main" id="{A41A23AC-D07C-7FEC-4E9C-099F3213CF92}"/>
+                <a16:creationId xmlns:a16="http://schemas.microsoft.com/office/drawing/2014/main" id="{C2EE0C19-EF2C-6B39-2311-ADB84CCC95A4}"/>
               </a:ext>
             </a:extLst>
           </p:cNvPr>
@@ -4845,7 +4845,7 @@
           <p:cNvPr id="4" name="TextBox 3">
             <a:extLst>
               <a:ext uri="{FF2B5EF4-FFF2-40B4-BE49-F238E27FC236}">
-                <a16:creationId xmlns:a16="http://schemas.microsoft.com/office/drawing/2014/main" id="{BD37D0E4-CACE-891C-A49C-C39505FFBAEB}"/>
+                <a16:creationId xmlns:a16="http://schemas.microsoft.com/office/drawing/2014/main" id="{8B59D67F-21E5-61D0-3798-934BD912875D}"/>
               </a:ext>
             </a:extLst>
           </p:cNvPr>
@@ -4878,7 +4878,7 @@
     </p:spTree>
     <p:extLst>
       <p:ext uri="{BB962C8B-B14F-4D97-AF65-F5344CB8AC3E}">
-        <p14:creationId xmlns:p14="http://schemas.microsoft.com/office/powerpoint/2010/main" val="2595246399"/>
+        <p14:creationId xmlns:p14="http://schemas.microsoft.com/office/powerpoint/2010/main" val="3942781505"/>
       </p:ext>
     </p:extLst>
   </p:cSld>
@@ -5050,7 +5050,7 @@
           <p:cNvPr id="2" name="Title 1">
             <a:extLst>
               <a:ext uri="{FF2B5EF4-FFF2-40B4-BE49-F238E27FC236}">
-                <a16:creationId xmlns:a16="http://schemas.microsoft.com/office/drawing/2014/main" id="{18D4D1FD-74D4-7EA6-4A95-4CF630A4C109}"/>
+                <a16:creationId xmlns:a16="http://schemas.microsoft.com/office/drawing/2014/main" id="{3B5223A4-8137-55DF-25DA-5A12258066EA}"/>
               </a:ext>
             </a:extLst>
           </p:cNvPr>
@@ -5078,7 +5078,7 @@
           <p:cNvPr id="3" name="Text Placeholder 2">
             <a:extLst>
               <a:ext uri="{FF2B5EF4-FFF2-40B4-BE49-F238E27FC236}">
-                <a16:creationId xmlns:a16="http://schemas.microsoft.com/office/drawing/2014/main" id="{ADBDD9A3-36CC-707C-AE81-B47C96D08E73}"/>
+                <a16:creationId xmlns:a16="http://schemas.microsoft.com/office/drawing/2014/main" id="{2345F252-C0F7-0215-0CC8-78099FF80826}"/>
               </a:ext>
             </a:extLst>
           </p:cNvPr>
@@ -5106,7 +5106,7 @@
           <p:cNvPr id="4" name="TextBox 3">
             <a:extLst>
               <a:ext uri="{FF2B5EF4-FFF2-40B4-BE49-F238E27FC236}">
-                <a16:creationId xmlns:a16="http://schemas.microsoft.com/office/drawing/2014/main" id="{09700262-F99B-6907-72D0-866F6D25629A}"/>
+                <a16:creationId xmlns:a16="http://schemas.microsoft.com/office/drawing/2014/main" id="{7EACDBEA-70AF-BDB3-49BD-AEAFE1AD424E}"/>
               </a:ext>
             </a:extLst>
           </p:cNvPr>
@@ -5142,7 +5142,7 @@
     </p:spTree>
     <p:extLst>
       <p:ext uri="{BB962C8B-B14F-4D97-AF65-F5344CB8AC3E}">
-        <p14:creationId xmlns:p14="http://schemas.microsoft.com/office/powerpoint/2010/main" val="633237236"/>
+        <p14:creationId xmlns:p14="http://schemas.microsoft.com/office/powerpoint/2010/main" val="3859046014"/>
       </p:ext>
     </p:extLst>
   </p:cSld>
@@ -5174,7 +5174,7 @@
           <p:cNvPr id="2" name="Title 1">
             <a:extLst>
               <a:ext uri="{FF2B5EF4-FFF2-40B4-BE49-F238E27FC236}">
-                <a16:creationId xmlns:a16="http://schemas.microsoft.com/office/drawing/2014/main" id="{FEA3C76E-5F2E-D5F6-6EBC-5EC679FDA341}"/>
+                <a16:creationId xmlns:a16="http://schemas.microsoft.com/office/drawing/2014/main" id="{AEABC49F-29B8-BD31-F842-1715DA28F874}"/>
               </a:ext>
             </a:extLst>
           </p:cNvPr>
@@ -5202,7 +5202,7 @@
           <p:cNvPr id="3" name="Text Placeholder 2">
             <a:extLst>
               <a:ext uri="{FF2B5EF4-FFF2-40B4-BE49-F238E27FC236}">
-                <a16:creationId xmlns:a16="http://schemas.microsoft.com/office/drawing/2014/main" id="{B99C0215-6140-2EE6-EE26-78AF7511A90A}"/>
+                <a16:creationId xmlns:a16="http://schemas.microsoft.com/office/drawing/2014/main" id="{5ADA2A53-9481-0B7B-CBAB-0C4BCE7B9357}"/>
               </a:ext>
             </a:extLst>
           </p:cNvPr>
@@ -5228,7 +5228,7 @@
     </p:spTree>
     <p:extLst>
       <p:ext uri="{BB962C8B-B14F-4D97-AF65-F5344CB8AC3E}">
-        <p14:creationId xmlns:p14="http://schemas.microsoft.com/office/powerpoint/2010/main" val="940555244"/>
+        <p14:creationId xmlns:p14="http://schemas.microsoft.com/office/powerpoint/2010/main" val="243608831"/>
       </p:ext>
     </p:extLst>
   </p:cSld>
@@ -5260,7 +5260,7 @@
           <p:cNvPr id="2" name="Title 1">
             <a:extLst>
               <a:ext uri="{FF2B5EF4-FFF2-40B4-BE49-F238E27FC236}">
-                <a16:creationId xmlns:a16="http://schemas.microsoft.com/office/drawing/2014/main" id="{85993E4A-2017-11AA-7269-0D1C22D42265}"/>
+                <a16:creationId xmlns:a16="http://schemas.microsoft.com/office/drawing/2014/main" id="{FF72257D-A32D-474B-C00E-85321A39286D}"/>
               </a:ext>
             </a:extLst>
           </p:cNvPr>
@@ -5288,7 +5288,7 @@
           <p:cNvPr id="3" name="Text Placeholder 2">
             <a:extLst>
               <a:ext uri="{FF2B5EF4-FFF2-40B4-BE49-F238E27FC236}">
-                <a16:creationId xmlns:a16="http://schemas.microsoft.com/office/drawing/2014/main" id="{C2758A64-F517-277B-E983-51E8EABE91E7}"/>
+                <a16:creationId xmlns:a16="http://schemas.microsoft.com/office/drawing/2014/main" id="{2E539C6F-6671-2C77-4287-16F69848C6BA}"/>
               </a:ext>
             </a:extLst>
           </p:cNvPr>
@@ -5307,6 +5307,56 @@
             <a:r>
               <a:rPr lang="en-US"/>
               <a:t>Body of slide 6</a:t>
+            </a:r>
+          </a:p>
+        </p:txBody>
+      </p:sp>
+      <p:sp>
+        <p:nvSpPr>
+          <p:cNvPr id="4" name="Rectangle 3">
+            <a:hlinkClick r:id="rId3"/>
+            <a:extLst>
+              <a:ext uri="{FF2B5EF4-FFF2-40B4-BE49-F238E27FC236}">
+                <a16:creationId xmlns:a16="http://schemas.microsoft.com/office/drawing/2014/main" id="{FB73C170-7154-B339-B947-6880E11F0CF5}"/>
+              </a:ext>
+            </a:extLst>
+          </p:cNvPr>
+          <p:cNvSpPr/>
+          <p:nvPr/>
+        </p:nvSpPr>
+        <p:spPr>
+          <a:xfrm>
+            <a:off x="7620000" y="4826000"/>
+            <a:ext cx="2794000" cy="1143000"/>
+          </a:xfrm>
+          <a:prstGeom prst="rect">
+            <a:avLst/>
+          </a:prstGeom>
+        </p:spPr>
+        <p:style>
+          <a:lnRef idx="2">
+            <a:schemeClr val="accent1">
+              <a:shade val="15000"/>
+            </a:schemeClr>
+          </a:lnRef>
+          <a:fillRef idx="1">
+            <a:schemeClr val="accent1"/>
+          </a:fillRef>
+          <a:effectRef idx="0">
+            <a:schemeClr val="accent1"/>
+          </a:effectRef>
+          <a:fontRef idx="minor">
+            <a:schemeClr val="lt1"/>
+          </a:fontRef>
+        </p:style>
+        <p:txBody>
+          <a:bodyPr rtlCol="0" anchor="ctr"/>
+          <a:lstStyle/>
+          <a:p>
+            <a:pPr algn="ctr"/>
+            <a:r>
+              <a:rPr lang="en-US"/>
+              <a:t>Other deck</a:t>
             </a:r>
           </a:p>
         </p:txBody>
@@ -5314,7 +5364,7 @@
     </p:spTree>
     <p:extLst>
       <p:ext uri="{BB962C8B-B14F-4D97-AF65-F5344CB8AC3E}">
-        <p14:creationId xmlns:p14="http://schemas.microsoft.com/office/powerpoint/2010/main" val="726886485"/>
+        <p14:creationId xmlns:p14="http://schemas.microsoft.com/office/powerpoint/2010/main" val="3995088195"/>
       </p:ext>
     </p:extLst>
   </p:cSld>
@@ -5346,7 +5396,7 @@
           <p:cNvPr id="2" name="Title 1">
             <a:extLst>
               <a:ext uri="{FF2B5EF4-FFF2-40B4-BE49-F238E27FC236}">
-                <a16:creationId xmlns:a16="http://schemas.microsoft.com/office/drawing/2014/main" id="{F58A9AD6-168E-E124-B17D-3046ED6E5D3B}"/>
+                <a16:creationId xmlns:a16="http://schemas.microsoft.com/office/drawing/2014/main" id="{27CE46D7-8078-0F8A-8FCF-718930845FBE}"/>
               </a:ext>
             </a:extLst>
           </p:cNvPr>
@@ -5374,7 +5424,7 @@
           <p:cNvPr id="3" name="Text Placeholder 2">
             <a:extLst>
               <a:ext uri="{FF2B5EF4-FFF2-40B4-BE49-F238E27FC236}">
-                <a16:creationId xmlns:a16="http://schemas.microsoft.com/office/drawing/2014/main" id="{EF9D2218-A919-1200-4383-D8E4B0A16BFA}"/>
+                <a16:creationId xmlns:a16="http://schemas.microsoft.com/office/drawing/2014/main" id="{5B5BBCC7-1B62-A132-86D1-807FCC26839B}"/>
               </a:ext>
             </a:extLst>
           </p:cNvPr>
@@ -5400,7 +5450,7 @@
     </p:spTree>
     <p:extLst>
       <p:ext uri="{BB962C8B-B14F-4D97-AF65-F5344CB8AC3E}">
-        <p14:creationId xmlns:p14="http://schemas.microsoft.com/office/powerpoint/2010/main" val="3562804796"/>
+        <p14:creationId xmlns:p14="http://schemas.microsoft.com/office/powerpoint/2010/main" val="3242900617"/>
       </p:ext>
     </p:extLst>
   </p:cSld>

</xml_diff>